<commit_message>
Apply Dracula dark theme formatting to PowerPoint generation
</commit_message>
<xml_diff>
--- a/presentation.pptx
+++ b/presentation.pptx
@@ -15,6 +15,7 @@
     <p:sldId id="263" r:id="rId14"/>
     <p:sldId id="264" r:id="rId15"/>
     <p:sldId id="265" r:id="rId16"/>
+    <p:sldId id="266" r:id="rId17"/>
   </p:sldIdLst>
   <p:sldSz cx="9144000" cy="6858000" type="screen4x3"/>
   <p:notesSz cx="6858000" cy="9144000"/>
@@ -3090,6 +3091,14 @@
 <file path=ppt/slides/slide1.xml><?xml version="1.0" encoding="utf-8"?>
 <p:sld xmlns:a="http://schemas.openxmlformats.org/drawingml/2006/main" xmlns:p="http://schemas.openxmlformats.org/presentationml/2006/main" xmlns:r="http://schemas.openxmlformats.org/officeDocument/2006/relationships">
   <p:cSld>
+    <p:bg>
+      <p:bgPr>
+        <a:solidFill>
+          <a:srgbClr val="282A36"/>
+        </a:solidFill>
+        <a:effectLst/>
+      </p:bgPr>
+    </p:bg>
     <p:spTree>
       <p:nvGrpSpPr>
         <p:cNvPr id="1" name=""/>
@@ -3113,6 +3122,12 @@
           <a:lstStyle/>
           <a:p>
             <a:r>
+              <a:rPr sz="4400" b="1">
+                <a:solidFill>
+                  <a:srgbClr val="FF79C6"/>
+                </a:solidFill>
+                <a:latin typeface="Segoe UI"/>
+              </a:rPr>
               <a:t>Multi-Threading &amp; Synchronisation</a:t>
             </a:r>
           </a:p>
@@ -3134,32 +3149,68 @@
           <a:lstStyle/>
           <a:p>
             <a:r>
+              <a:rPr sz="1800" b="0">
+                <a:solidFill>
+                  <a:srgbClr val="F8F8F2"/>
+                </a:solidFill>
+                <a:latin typeface="Segoe UI"/>
+              </a:rPr>
               <a:t>Maîtriser l'exécution parallèle et éviter le chaos.</a:t>
             </a:r>
           </a:p>
           <a:p/>
           <a:p>
             <a:r>
+              <a:rPr sz="1800" b="0">
+                <a:solidFill>
+                  <a:srgbClr val="F8F8F2"/>
+                </a:solidFill>
+                <a:latin typeface="Segoe UI"/>
+              </a:rPr>
               <a:t>Présenté par :</a:t>
             </a:r>
           </a:p>
           <a:p>
             <a:r>
+              <a:rPr sz="1800" b="0">
+                <a:solidFill>
+                  <a:srgbClr val="F8F8F2"/>
+                </a:solidFill>
+                <a:latin typeface="Segoe UI"/>
+              </a:rPr>
               <a:t>👤 Nacim Oualla</a:t>
             </a:r>
           </a:p>
           <a:p>
             <a:r>
+              <a:rPr sz="1800" b="0">
+                <a:solidFill>
+                  <a:srgbClr val="F8F8F2"/>
+                </a:solidFill>
+                <a:latin typeface="Segoe UI"/>
+              </a:rPr>
               <a:t>👤 Essaqy Douae</a:t>
             </a:r>
           </a:p>
           <a:p>
             <a:r>
+              <a:rPr sz="1800" b="0">
+                <a:solidFill>
+                  <a:srgbClr val="F8F8F2"/>
+                </a:solidFill>
+                <a:latin typeface="Segoe UI"/>
+              </a:rPr>
               <a:t>👤 Yassmine Mouden</a:t>
             </a:r>
           </a:p>
           <a:p>
             <a:r>
+              <a:rPr sz="1800" b="0">
+                <a:solidFill>
+                  <a:srgbClr val="F8F8F2"/>
+                </a:solidFill>
+                <a:latin typeface="Segoe UI"/>
+              </a:rPr>
               <a:t>👤 Ouachikh Zakaria</a:t>
             </a:r>
           </a:p>
@@ -3176,6 +3227,14 @@
 <file path=ppt/slides/slide10.xml><?xml version="1.0" encoding="utf-8"?>
 <p:sld xmlns:a="http://schemas.openxmlformats.org/drawingml/2006/main" xmlns:p="http://schemas.openxmlformats.org/presentationml/2006/main" xmlns:r="http://schemas.openxmlformats.org/officeDocument/2006/relationships">
   <p:cSld>
+    <p:bg>
+      <p:bgPr>
+        <a:solidFill>
+          <a:srgbClr val="282A36"/>
+        </a:solidFill>
+        <a:effectLst/>
+      </p:bgPr>
+    </p:bg>
     <p:spTree>
       <p:nvGrpSpPr>
         <p:cNvPr id="1" name=""/>
@@ -3190,6 +3249,124 @@
             <a:spLocks noGrp="1"/>
           </p:cNvSpPr>
           <p:nvPr>
+            <p:ph type="title"/>
+          </p:nvPr>
+        </p:nvSpPr>
+        <p:spPr/>
+        <p:txBody>
+          <a:bodyPr/>
+          <a:lstStyle/>
+          <a:p>
+            <a:r>
+              <a:rPr sz="3600" b="1">
+                <a:solidFill>
+                  <a:srgbClr val="FF79C6"/>
+                </a:solidFill>
+                <a:latin typeface="Segoe UI"/>
+              </a:rPr>
+              <a:t>Bonnes Pratiques ✅</a:t>
+            </a:r>
+          </a:p>
+        </p:txBody>
+      </p:sp>
+      <p:sp>
+        <p:nvSpPr>
+          <p:cNvPr id="3" name="Content Placeholder 2"/>
+          <p:cNvSpPr>
+            <a:spLocks noGrp="1"/>
+          </p:cNvSpPr>
+          <p:nvPr>
+            <p:ph idx="1"/>
+          </p:nvPr>
+        </p:nvSpPr>
+        <p:spPr/>
+        <p:txBody>
+          <a:bodyPr/>
+          <a:lstStyle/>
+          <a:p/>
+          <a:p>
+            <a:pPr>
+              <a:spcAft>
+                <a:spcPts val="1400"/>
+              </a:spcAft>
+            </a:pPr>
+            <a:r>
+              <a:rPr sz="2200">
+                <a:solidFill>
+                  <a:srgbClr val="F8F8F2"/>
+                </a:solidFill>
+                <a:latin typeface="Segoe UI"/>
+              </a:rPr>
+              <a:t>✨ Minimiser les données partagées entre les threads.</a:t>
+            </a:r>
+          </a:p>
+          <a:p>
+            <a:pPr>
+              <a:spcAft>
+                <a:spcPts val="1400"/>
+              </a:spcAft>
+            </a:pPr>
+            <a:r>
+              <a:rPr sz="2200">
+                <a:solidFill>
+                  <a:srgbClr val="F8F8F2"/>
+                </a:solidFill>
+                <a:latin typeface="Segoe UI"/>
+              </a:rPr>
+              <a:t>⏱️ Garder les sections critiques (verrouillées) très courtes.</a:t>
+            </a:r>
+          </a:p>
+          <a:p>
+            <a:pPr>
+              <a:spcAft>
+                <a:spcPts val="1400"/>
+              </a:spcAft>
+            </a:pPr>
+            <a:r>
+              <a:rPr sz="2200">
+                <a:solidFill>
+                  <a:srgbClr val="F8F8F2"/>
+                </a:solidFill>
+                <a:latin typeface="Segoe UI"/>
+              </a:rPr>
+              <a:t>🔓 Toujours utiliser unlock() dans un bloc finally.</a:t>
+            </a:r>
+          </a:p>
+        </p:txBody>
+      </p:sp>
+    </p:spTree>
+  </p:cSld>
+  <p:clrMapOvr>
+    <a:masterClrMapping/>
+  </p:clrMapOvr>
+</p:sld>
+</file>
+
+<file path=ppt/slides/slide11.xml><?xml version="1.0" encoding="utf-8"?>
+<p:sld xmlns:a="http://schemas.openxmlformats.org/drawingml/2006/main" xmlns:p="http://schemas.openxmlformats.org/presentationml/2006/main" xmlns:r="http://schemas.openxmlformats.org/officeDocument/2006/relationships">
+  <p:cSld>
+    <p:bg>
+      <p:bgPr>
+        <a:solidFill>
+          <a:srgbClr val="282A36"/>
+        </a:solidFill>
+        <a:effectLst/>
+      </p:bgPr>
+    </p:bg>
+    <p:spTree>
+      <p:nvGrpSpPr>
+        <p:cNvPr id="1" name=""/>
+        <p:cNvGrpSpPr/>
+        <p:nvPr/>
+      </p:nvGrpSpPr>
+      <p:grpSpPr/>
+      <p:sp>
+        <p:nvSpPr>
+          <p:cNvPr id="2" name="Title 1"/>
+          <p:cNvSpPr>
+            <a:spLocks noGrp="1"/>
+          </p:cNvSpPr>
+          <p:nvPr>
             <p:ph type="ctrTitle"/>
           </p:nvPr>
         </p:nvSpPr>
@@ -3199,6 +3376,12 @@
           <a:lstStyle/>
           <a:p>
             <a:r>
+              <a:rPr sz="5000" b="1">
+                <a:solidFill>
+                  <a:srgbClr val="50FA7B"/>
+                </a:solidFill>
+                <a:latin typeface="Segoe UI"/>
+              </a:rPr>
               <a:t>Merci !</a:t>
             </a:r>
           </a:p>
@@ -3220,6 +3403,12 @@
           <a:lstStyle/>
           <a:p>
             <a:r>
+              <a:rPr sz="2800" b="0">
+                <a:solidFill>
+                  <a:srgbClr val="F8F8F2"/>
+                </a:solidFill>
+                <a:latin typeface="Segoe UI"/>
+              </a:rPr>
               <a:t>Avez-vous des questions ?</a:t>
             </a:r>
           </a:p>
@@ -3236,6 +3425,14 @@
 <file path=ppt/slides/slide2.xml><?xml version="1.0" encoding="utf-8"?>
 <p:sld xmlns:a="http://schemas.openxmlformats.org/drawingml/2006/main" xmlns:p="http://schemas.openxmlformats.org/presentationml/2006/main" xmlns:r="http://schemas.openxmlformats.org/officeDocument/2006/relationships">
   <p:cSld>
+    <p:bg>
+      <p:bgPr>
+        <a:solidFill>
+          <a:srgbClr val="282A36"/>
+        </a:solidFill>
+        <a:effectLst/>
+      </p:bgPr>
+    </p:bg>
     <p:spTree>
       <p:nvGrpSpPr>
         <p:cNvPr id="1" name=""/>
@@ -3259,6 +3456,12 @@
           <a:lstStyle/>
           <a:p>
             <a:r>
+              <a:rPr sz="3600" b="1">
+                <a:solidFill>
+                  <a:srgbClr val="FF79C6"/>
+                </a:solidFill>
+                <a:latin typeface="Segoe UI"/>
+              </a:rPr>
               <a:t>Qu'est-ce qu'un Thread ?</a:t>
             </a:r>
           </a:p>
@@ -3278,18 +3481,52 @@
         <p:txBody>
           <a:bodyPr/>
           <a:lstStyle/>
-          <a:p>
-            <a:r>
+          <a:p/>
+          <a:p>
+            <a:pPr>
+              <a:spcAft>
+                <a:spcPts val="1400"/>
+              </a:spcAft>
+            </a:pPr>
+            <a:r>
+              <a:rPr sz="2200">
+                <a:solidFill>
+                  <a:srgbClr val="F8F8F2"/>
+                </a:solidFill>
+                <a:latin typeface="Segoe UI"/>
+              </a:rPr>
               <a:t>Un processus est une application en cours d'exécution.</a:t>
             </a:r>
           </a:p>
           <a:p>
-            <a:r>
+            <a:pPr>
+              <a:spcAft>
+                <a:spcPts val="1400"/>
+              </a:spcAft>
+            </a:pPr>
+            <a:r>
+              <a:rPr sz="2200">
+                <a:solidFill>
+                  <a:srgbClr val="F8F8F2"/>
+                </a:solidFill>
+                <a:latin typeface="Segoe UI"/>
+              </a:rPr>
               <a:t>Un thread est la plus petite unité de traitement.</a:t>
             </a:r>
           </a:p>
           <a:p>
-            <a:r>
+            <a:pPr>
+              <a:spcAft>
+                <a:spcPts val="1400"/>
+              </a:spcAft>
+            </a:pPr>
+            <a:r>
+              <a:rPr sz="2200">
+                <a:solidFill>
+                  <a:srgbClr val="F8F8F2"/>
+                </a:solidFill>
+                <a:latin typeface="Segoe UI"/>
+              </a:rPr>
               <a:t>Attention : Les threads partagent le même espace mémoire !</a:t>
             </a:r>
           </a:p>
@@ -3306,6 +3543,14 @@
 <file path=ppt/slides/slide3.xml><?xml version="1.0" encoding="utf-8"?>
 <p:sld xmlns:a="http://schemas.openxmlformats.org/drawingml/2006/main" xmlns:p="http://schemas.openxmlformats.org/presentationml/2006/main" xmlns:r="http://schemas.openxmlformats.org/officeDocument/2006/relationships">
   <p:cSld>
+    <p:bg>
+      <p:bgPr>
+        <a:solidFill>
+          <a:srgbClr val="282A36"/>
+        </a:solidFill>
+        <a:effectLst/>
+      </p:bgPr>
+    </p:bg>
     <p:spTree>
       <p:nvGrpSpPr>
         <p:cNvPr id="1" name=""/>
@@ -3329,7 +3574,13 @@
           <a:lstStyle/>
           <a:p>
             <a:r>
-              <a:t>Pourquoi le Multi-Threading ?</a:t>
+              <a:rPr sz="3600" b="1">
+                <a:solidFill>
+                  <a:srgbClr val="FF79C6"/>
+                </a:solidFill>
+                <a:latin typeface="Segoe UI"/>
+              </a:rPr>
+              <a:t>Cas d'usage Pratiques</a:t>
             </a:r>
           </a:p>
         </p:txBody>
@@ -3348,19 +3599,53 @@
         <p:txBody>
           <a:bodyPr/>
           <a:lstStyle/>
-          <a:p>
-            <a:r>
-              <a:t>1. Réactivité ⚡: L'interface utilisateur ne gèle pas pendant les longs calculs en arrière-plan.</a:t>
-            </a:r>
-          </a:p>
-          <a:p>
-            <a:r>
-              <a:t>2. Performance 🚀: Exploitation maximale et simultanée des processeurs multi-cœurs modernes.</a:t>
-            </a:r>
-          </a:p>
-          <a:p>
-            <a:r>
-              <a:t>3. Économie 💾: Créer un thread coûte beaucoup moins de mémoire que de créer un nouveau processus.</a:t>
+          <a:p/>
+          <a:p>
+            <a:pPr>
+              <a:spcAft>
+                <a:spcPts val="1400"/>
+              </a:spcAft>
+            </a:pPr>
+            <a:r>
+              <a:rPr sz="2200">
+                <a:solidFill>
+                  <a:srgbClr val="F8F8F2"/>
+                </a:solidFill>
+                <a:latin typeface="Segoe UI"/>
+              </a:rPr>
+              <a:t>Jeux Vidéo 🎮 : Rendu graphique, physique, IA et son (threads distincts).</a:t>
+            </a:r>
+          </a:p>
+          <a:p>
+            <a:pPr>
+              <a:spcAft>
+                <a:spcPts val="1400"/>
+              </a:spcAft>
+            </a:pPr>
+            <a:r>
+              <a:rPr sz="2200">
+                <a:solidFill>
+                  <a:srgbClr val="F8F8F2"/>
+                </a:solidFill>
+                <a:latin typeface="Segoe UI"/>
+              </a:rPr>
+              <a:t>Serveurs Web 🌐 : Apache/Tomcat gère chaque requête via un thread.</a:t>
+            </a:r>
+          </a:p>
+          <a:p>
+            <a:pPr>
+              <a:spcAft>
+                <a:spcPts val="1400"/>
+              </a:spcAft>
+            </a:pPr>
+            <a:r>
+              <a:rPr sz="2200">
+                <a:solidFill>
+                  <a:srgbClr val="F8F8F2"/>
+                </a:solidFill>
+                <a:latin typeface="Segoe UI"/>
+              </a:rPr>
+              <a:t>Big Data 📊 : Traitement massivement parallèle, encodage vidéo, rendu 3D.</a:t>
             </a:r>
           </a:p>
         </p:txBody>
@@ -3376,6 +3661,14 @@
 <file path=ppt/slides/slide4.xml><?xml version="1.0" encoding="utf-8"?>
 <p:sld xmlns:a="http://schemas.openxmlformats.org/drawingml/2006/main" xmlns:p="http://schemas.openxmlformats.org/presentationml/2006/main" xmlns:r="http://schemas.openxmlformats.org/officeDocument/2006/relationships">
   <p:cSld>
+    <p:bg>
+      <p:bgPr>
+        <a:solidFill>
+          <a:srgbClr val="282A36"/>
+        </a:solidFill>
+        <a:effectLst/>
+      </p:bgPr>
+    </p:bg>
     <p:spTree>
       <p:nvGrpSpPr>
         <p:cNvPr id="1" name=""/>
@@ -3399,7 +3692,13 @@
           <a:lstStyle/>
           <a:p>
             <a:r>
-              <a:t>Le Danger : Race Conditions</a:t>
+              <a:rPr sz="3600" b="1">
+                <a:solidFill>
+                  <a:srgbClr val="FF79C6"/>
+                </a:solidFill>
+                <a:latin typeface="Segoe UI"/>
+              </a:rPr>
+              <a:t>Pourquoi le Multi-Threading ?</a:t>
             </a:r>
           </a:p>
         </p:txBody>
@@ -3418,24 +3717,53 @@
         <p:txBody>
           <a:bodyPr/>
           <a:lstStyle/>
-          <a:p>
-            <a:r>
-              <a:t>Que se passe-t-il si deux threads modifient la même donnée en même temps ?</a:t>
-            </a:r>
-          </a:p>
-          <a:p>
-            <a:r>
-              <a:t>-&gt; Données corrompues</a:t>
-            </a:r>
-          </a:p>
-          <a:p>
-            <a:r>
-              <a:t>-&gt; Comportements imprévisibles</a:t>
-            </a:r>
-          </a:p>
-          <a:p>
-            <a:r>
-              <a:t>-&gt; Crash de l'application</a:t>
+          <a:p/>
+          <a:p>
+            <a:pPr>
+              <a:spcAft>
+                <a:spcPts val="1400"/>
+              </a:spcAft>
+            </a:pPr>
+            <a:r>
+              <a:rPr sz="2200">
+                <a:solidFill>
+                  <a:srgbClr val="F8F8F2"/>
+                </a:solidFill>
+                <a:latin typeface="Segoe UI"/>
+              </a:rPr>
+              <a:t>1. Réactivité ⚡: L'interface utilisateur ne gèle pas.</a:t>
+            </a:r>
+          </a:p>
+          <a:p>
+            <a:pPr>
+              <a:spcAft>
+                <a:spcPts val="1400"/>
+              </a:spcAft>
+            </a:pPr>
+            <a:r>
+              <a:rPr sz="2200">
+                <a:solidFill>
+                  <a:srgbClr val="F8F8F2"/>
+                </a:solidFill>
+                <a:latin typeface="Segoe UI"/>
+              </a:rPr>
+              <a:t>2. Performance 🚀: Exploitation maximale des processeurs multi-cœurs.</a:t>
+            </a:r>
+          </a:p>
+          <a:p>
+            <a:pPr>
+              <a:spcAft>
+                <a:spcPts val="1400"/>
+              </a:spcAft>
+            </a:pPr>
+            <a:r>
+              <a:rPr sz="2200">
+                <a:solidFill>
+                  <a:srgbClr val="F8F8F2"/>
+                </a:solidFill>
+                <a:latin typeface="Segoe UI"/>
+              </a:rPr>
+              <a:t>3. Économie 💾: Créer un thread coûte beaucoup moins de mémoire.</a:t>
             </a:r>
           </a:p>
         </p:txBody>
@@ -3451,6 +3779,14 @@
 <file path=ppt/slides/slide5.xml><?xml version="1.0" encoding="utf-8"?>
 <p:sld xmlns:a="http://schemas.openxmlformats.org/drawingml/2006/main" xmlns:p="http://schemas.openxmlformats.org/presentationml/2006/main" xmlns:r="http://schemas.openxmlformats.org/officeDocument/2006/relationships">
   <p:cSld>
+    <p:bg>
+      <p:bgPr>
+        <a:solidFill>
+          <a:srgbClr val="282A36"/>
+        </a:solidFill>
+        <a:effectLst/>
+      </p:bgPr>
+    </p:bg>
     <p:spTree>
       <p:nvGrpSpPr>
         <p:cNvPr id="1" name=""/>
@@ -3474,7 +3810,13 @@
           <a:lstStyle/>
           <a:p>
             <a:r>
-              <a:t>La Synchronisation 🛡️</a:t>
+              <a:rPr sz="3600" b="1">
+                <a:solidFill>
+                  <a:srgbClr val="FF79C6"/>
+                </a:solidFill>
+                <a:latin typeface="Segoe UI"/>
+              </a:rPr>
+              <a:t>Le Danger : Race Conditions</a:t>
             </a:r>
           </a:p>
         </p:txBody>
@@ -3493,24 +3835,69 @@
         <p:txBody>
           <a:bodyPr/>
           <a:lstStyle/>
-          <a:p>
-            <a:r>
-              <a:t>Mettre de l'ordre dans l'exécution avec des verrous.</a:t>
-            </a:r>
-          </a:p>
-          <a:p>
-            <a:r>
-              <a:t>Mutex : Verrou d'exclusion mutuelle. Un seul thread à la fois.</a:t>
-            </a:r>
-          </a:p>
-          <a:p>
-            <a:r>
-              <a:t>Sémaphore : Limitation d'accès. N threads maximum autorisés.</a:t>
-            </a:r>
-          </a:p>
-          <a:p>
-            <a:r>
-              <a:t>Moniteur : Approche Objet. Méthodes synchronisées nativement.</a:t>
+          <a:p/>
+          <a:p>
+            <a:pPr>
+              <a:spcAft>
+                <a:spcPts val="1400"/>
+              </a:spcAft>
+            </a:pPr>
+            <a:r>
+              <a:rPr sz="2200">
+                <a:solidFill>
+                  <a:srgbClr val="F8F8F2"/>
+                </a:solidFill>
+                <a:latin typeface="Segoe UI"/>
+              </a:rPr>
+              <a:t>Que se passe-t-il si deux threads modifient la même donnée ?</a:t>
+            </a:r>
+          </a:p>
+          <a:p>
+            <a:pPr>
+              <a:spcAft>
+                <a:spcPts val="1400"/>
+              </a:spcAft>
+            </a:pPr>
+            <a:r>
+              <a:rPr sz="2200">
+                <a:solidFill>
+                  <a:srgbClr val="F8F8F2"/>
+                </a:solidFill>
+                <a:latin typeface="Segoe UI"/>
+              </a:rPr>
+              <a:t>❌ Données corrompues</a:t>
+            </a:r>
+          </a:p>
+          <a:p>
+            <a:pPr>
+              <a:spcAft>
+                <a:spcPts val="1400"/>
+              </a:spcAft>
+            </a:pPr>
+            <a:r>
+              <a:rPr sz="2200">
+                <a:solidFill>
+                  <a:srgbClr val="F8F8F2"/>
+                </a:solidFill>
+                <a:latin typeface="Segoe UI"/>
+              </a:rPr>
+              <a:t>❌ Comportements imprévisibles</a:t>
+            </a:r>
+          </a:p>
+          <a:p>
+            <a:pPr>
+              <a:spcAft>
+                <a:spcPts val="1400"/>
+              </a:spcAft>
+            </a:pPr>
+            <a:r>
+              <a:rPr sz="2200">
+                <a:solidFill>
+                  <a:srgbClr val="F8F8F2"/>
+                </a:solidFill>
+                <a:latin typeface="Segoe UI"/>
+              </a:rPr>
+              <a:t>❌ Crash de l'application</a:t>
             </a:r>
           </a:p>
         </p:txBody>
@@ -3526,6 +3913,14 @@
 <file path=ppt/slides/slide6.xml><?xml version="1.0" encoding="utf-8"?>
 <p:sld xmlns:a="http://schemas.openxmlformats.org/drawingml/2006/main" xmlns:p="http://schemas.openxmlformats.org/presentationml/2006/main" xmlns:r="http://schemas.openxmlformats.org/officeDocument/2006/relationships">
   <p:cSld>
+    <p:bg>
+      <p:bgPr>
+        <a:solidFill>
+          <a:srgbClr val="282A36"/>
+        </a:solidFill>
+        <a:effectLst/>
+      </p:bgPr>
+    </p:bg>
     <p:spTree>
       <p:nvGrpSpPr>
         <p:cNvPr id="1" name=""/>
@@ -3549,7 +3944,13 @@
           <a:lstStyle/>
           <a:p>
             <a:r>
-              <a:t>Le Cauchemar : Deadlocks</a:t>
+              <a:rPr sz="3600" b="1">
+                <a:solidFill>
+                  <a:srgbClr val="FF79C6"/>
+                </a:solidFill>
+                <a:latin typeface="Segoe UI"/>
+              </a:rPr>
+              <a:t>La Synchronisation 🛡️</a:t>
             </a:r>
           </a:p>
         </p:txBody>
@@ -3568,19 +3969,69 @@
         <p:txBody>
           <a:bodyPr/>
           <a:lstStyle/>
-          <a:p>
-            <a:r>
-              <a:t>L'Interblocage fatal.</a:t>
-            </a:r>
-          </a:p>
-          <a:p>
-            <a:r>
-              <a:t>"Le Thread A attend que le Thread B lâche une ressource... mais le Thread B attend que le Thread A lâche la sienne."</a:t>
-            </a:r>
-          </a:p>
-          <a:p>
-            <a:r>
-              <a:t>Résultat : Tout se fige. 🛑</a:t>
+          <a:p/>
+          <a:p>
+            <a:pPr>
+              <a:spcAft>
+                <a:spcPts val="1400"/>
+              </a:spcAft>
+            </a:pPr>
+            <a:r>
+              <a:rPr sz="2200">
+                <a:solidFill>
+                  <a:srgbClr val="F8F8F2"/>
+                </a:solidFill>
+                <a:latin typeface="Segoe UI"/>
+              </a:rPr>
+              <a:t>Mettre de l'ordre dans l'exécution avec des verrous.</a:t>
+            </a:r>
+          </a:p>
+          <a:p>
+            <a:pPr>
+              <a:spcAft>
+                <a:spcPts val="1400"/>
+              </a:spcAft>
+            </a:pPr>
+            <a:r>
+              <a:rPr sz="2200">
+                <a:solidFill>
+                  <a:srgbClr val="F8F8F2"/>
+                </a:solidFill>
+                <a:latin typeface="Segoe UI"/>
+              </a:rPr>
+              <a:t>🔒 Mutex : Verrou d'exclusion mutuelle. Un seul thread.</a:t>
+            </a:r>
+          </a:p>
+          <a:p>
+            <a:pPr>
+              <a:spcAft>
+                <a:spcPts val="1400"/>
+              </a:spcAft>
+            </a:pPr>
+            <a:r>
+              <a:rPr sz="2200">
+                <a:solidFill>
+                  <a:srgbClr val="F8F8F2"/>
+                </a:solidFill>
+                <a:latin typeface="Segoe UI"/>
+              </a:rPr>
+              <a:t>🚥 Sémaphore : Limitation d'accès. N threads maximum.</a:t>
+            </a:r>
+          </a:p>
+          <a:p>
+            <a:pPr>
+              <a:spcAft>
+                <a:spcPts val="1400"/>
+              </a:spcAft>
+            </a:pPr>
+            <a:r>
+              <a:rPr sz="2200">
+                <a:solidFill>
+                  <a:srgbClr val="F8F8F2"/>
+                </a:solidFill>
+                <a:latin typeface="Segoe UI"/>
+              </a:rPr>
+              <a:t>📦 Moniteur : Approche Objet. Méthodes synchronisées nativement.</a:t>
             </a:r>
           </a:p>
         </p:txBody>
@@ -3596,6 +4047,14 @@
 <file path=ppt/slides/slide7.xml><?xml version="1.0" encoding="utf-8"?>
 <p:sld xmlns:a="http://schemas.openxmlformats.org/drawingml/2006/main" xmlns:p="http://schemas.openxmlformats.org/presentationml/2006/main" xmlns:r="http://schemas.openxmlformats.org/officeDocument/2006/relationships">
   <p:cSld>
+    <p:bg>
+      <p:bgPr>
+        <a:solidFill>
+          <a:srgbClr val="282A36"/>
+        </a:solidFill>
+        <a:effectLst/>
+      </p:bgPr>
+    </p:bg>
     <p:spTree>
       <p:nvGrpSpPr>
         <p:cNvPr id="1" name=""/>
@@ -3619,6 +4078,146 @@
           <a:lstStyle/>
           <a:p>
             <a:r>
+              <a:rPr sz="3600" b="1">
+                <a:solidFill>
+                  <a:srgbClr val="FF79C6"/>
+                </a:solidFill>
+                <a:latin typeface="Segoe UI"/>
+              </a:rPr>
+              <a:t>Le Cauchemar : Deadlocks</a:t>
+            </a:r>
+          </a:p>
+        </p:txBody>
+      </p:sp>
+      <p:sp>
+        <p:nvSpPr>
+          <p:cNvPr id="3" name="Content Placeholder 2"/>
+          <p:cNvSpPr>
+            <a:spLocks noGrp="1"/>
+          </p:cNvSpPr>
+          <p:nvPr>
+            <p:ph idx="1"/>
+          </p:nvPr>
+        </p:nvSpPr>
+        <p:spPr/>
+        <p:txBody>
+          <a:bodyPr/>
+          <a:lstStyle/>
+          <a:p/>
+          <a:p>
+            <a:pPr>
+              <a:spcAft>
+                <a:spcPts val="1400"/>
+              </a:spcAft>
+            </a:pPr>
+            <a:r>
+              <a:rPr sz="2200">
+                <a:solidFill>
+                  <a:srgbClr val="F8F8F2"/>
+                </a:solidFill>
+                <a:latin typeface="Segoe UI"/>
+              </a:rPr>
+              <a:t>L'Interblocage fatal.</a:t>
+            </a:r>
+          </a:p>
+          <a:p>
+            <a:pPr>
+              <a:spcAft>
+                <a:spcPts val="1400"/>
+              </a:spcAft>
+            </a:pPr>
+            <a:r>
+              <a:rPr sz="2200">
+                <a:solidFill>
+                  <a:srgbClr val="F8F8F2"/>
+                </a:solidFill>
+                <a:latin typeface="Segoe UI"/>
+              </a:rPr>
+              <a:t>"Le Thread A attend que le Thread B lâche une ressource...</a:t>
+            </a:r>
+          </a:p>
+          <a:p>
+            <a:pPr>
+              <a:spcAft>
+                <a:spcPts val="1400"/>
+              </a:spcAft>
+            </a:pPr>
+            <a:r>
+              <a:rPr sz="2200">
+                <a:solidFill>
+                  <a:srgbClr val="F8F8F2"/>
+                </a:solidFill>
+                <a:latin typeface="Segoe UI"/>
+              </a:rPr>
+              <a:t>...mais le Thread B attend que le Thread A lâche la sienne."</a:t>
+            </a:r>
+          </a:p>
+          <a:p>
+            <a:pPr>
+              <a:spcAft>
+                <a:spcPts val="1400"/>
+              </a:spcAft>
+            </a:pPr>
+            <a:r>
+              <a:rPr sz="2200">
+                <a:solidFill>
+                  <a:srgbClr val="F8F8F2"/>
+                </a:solidFill>
+                <a:latin typeface="Segoe UI"/>
+              </a:rPr>
+              <a:t>🛑 Résultat : Tout se fige.</a:t>
+            </a:r>
+          </a:p>
+        </p:txBody>
+      </p:sp>
+    </p:spTree>
+  </p:cSld>
+  <p:clrMapOvr>
+    <a:masterClrMapping/>
+  </p:clrMapOvr>
+</p:sld>
+</file>
+
+<file path=ppt/slides/slide8.xml><?xml version="1.0" encoding="utf-8"?>
+<p:sld xmlns:a="http://schemas.openxmlformats.org/drawingml/2006/main" xmlns:p="http://schemas.openxmlformats.org/presentationml/2006/main" xmlns:r="http://schemas.openxmlformats.org/officeDocument/2006/relationships">
+  <p:cSld>
+    <p:bg>
+      <p:bgPr>
+        <a:solidFill>
+          <a:srgbClr val="282A36"/>
+        </a:solidFill>
+        <a:effectLst/>
+      </p:bgPr>
+    </p:bg>
+    <p:spTree>
+      <p:nvGrpSpPr>
+        <p:cNvPr id="1" name=""/>
+        <p:cNvGrpSpPr/>
+        <p:nvPr/>
+      </p:nvGrpSpPr>
+      <p:grpSpPr/>
+      <p:sp>
+        <p:nvSpPr>
+          <p:cNvPr id="2" name="Title 1"/>
+          <p:cNvSpPr>
+            <a:spLocks noGrp="1"/>
+          </p:cNvSpPr>
+          <p:nvPr>
+            <p:ph type="title"/>
+          </p:nvPr>
+        </p:nvSpPr>
+        <p:spPr/>
+        <p:txBody>
+          <a:bodyPr/>
+          <a:lstStyle/>
+          <a:p>
+            <a:r>
+              <a:rPr sz="3600" b="1">
+                <a:solidFill>
+                  <a:srgbClr val="FF79C6"/>
+                </a:solidFill>
+                <a:latin typeface="Segoe UI"/>
+              </a:rPr>
               <a:t>Processus vs Thread</a:t>
             </a:r>
           </a:p>
@@ -3633,8 +4232,8 @@
           <p:nvPr/>
         </p:nvGraphicFramePr>
         <p:xfrm>
-          <a:off x="914400" y="1828800"/>
-          <a:ext cx="7315200" cy="2743200"/>
+          <a:off x="457200" y="1645920"/>
+          <a:ext cx="8229600" cy="2743200"/>
         </p:xfrm>
         <a:graphic>
           <a:graphicData uri="http://schemas.openxmlformats.org/drawingml/2006/table">
@@ -3643,8 +4242,8 @@
                 <a:tableStyleId>{5C22544A-7EE6-4342-B048-85BDC9FD1C3A}</a:tableStyleId>
               </a:tblPr>
               <a:tblGrid>
-                <a:gridCol w="3657600"/>
-                <a:gridCol w="3657600"/>
+                <a:gridCol w="4114800"/>
+                <a:gridCol w="4114800"/>
               </a:tblGrid>
               <a:tr h="548640">
                 <a:tc>
@@ -3653,6 +4252,12 @@
                     <a:lstStyle/>
                     <a:p>
                       <a:r>
+                        <a:rPr sz="2000" b="1">
+                          <a:solidFill>
+                            <a:srgbClr val="FF79C6"/>
+                          </a:solidFill>
+                          <a:latin typeface="Segoe UI"/>
+                        </a:rPr>
                         <a:t>Processus</a:t>
                       </a:r>
                     </a:p>
@@ -3665,6 +4270,12 @@
                     <a:lstStyle/>
                     <a:p>
                       <a:r>
+                        <a:rPr sz="2000" b="1">
+                          <a:solidFill>
+                            <a:srgbClr val="FF79C6"/>
+                          </a:solidFill>
+                          <a:latin typeface="Segoe UI"/>
+                        </a:rPr>
                         <a:t>Thread</a:t>
                       </a:r>
                     </a:p>
@@ -3679,6 +4290,12 @@
                     <a:lstStyle/>
                     <a:p>
                       <a:r>
+                        <a:rPr sz="1800" b="0">
+                          <a:solidFill>
+                            <a:srgbClr val="F8F8F2"/>
+                          </a:solidFill>
+                          <a:latin typeface="Segoe UI"/>
+                        </a:rPr>
                         <a:t>Espaces mémoire isolés</a:t>
                       </a:r>
                     </a:p>
@@ -3691,6 +4308,12 @@
                     <a:lstStyle/>
                     <a:p>
                       <a:r>
+                        <a:rPr sz="1800" b="0">
+                          <a:solidFill>
+                            <a:srgbClr val="F8F8F2"/>
+                          </a:solidFill>
+                          <a:latin typeface="Segoe UI"/>
+                        </a:rPr>
                         <a:t>Mémoire partagée</a:t>
                       </a:r>
                     </a:p>
@@ -3705,6 +4328,12 @@
                     <a:lstStyle/>
                     <a:p>
                       <a:r>
+                        <a:rPr sz="1800" b="0">
+                          <a:solidFill>
+                            <a:srgbClr val="F8F8F2"/>
+                          </a:solidFill>
+                          <a:latin typeface="Segoe UI"/>
+                        </a:rPr>
                         <a:t>Lourd (Temps CPU)</a:t>
                       </a:r>
                     </a:p>
@@ -3717,6 +4346,12 @@
                     <a:lstStyle/>
                     <a:p>
                       <a:r>
+                        <a:rPr sz="1800" b="0">
+                          <a:solidFill>
+                            <a:srgbClr val="F8F8F2"/>
+                          </a:solidFill>
+                          <a:latin typeface="Segoe UI"/>
+                        </a:rPr>
                         <a:t>Léger et rapide</a:t>
                       </a:r>
                     </a:p>
@@ -3731,7 +4366,13 @@
                     <a:lstStyle/>
                     <a:p>
                       <a:r>
-                        <a:t>Isolation (si l'un plante, l'autre survit)</a:t>
+                        <a:rPr sz="1800" b="0">
+                          <a:solidFill>
+                            <a:srgbClr val="F8F8F2"/>
+                          </a:solidFill>
+                          <a:latin typeface="Segoe UI"/>
+                        </a:rPr>
+                        <a:t>Forte isolation</a:t>
                       </a:r>
                     </a:p>
                   </a:txBody>
@@ -3743,6 +4384,12 @@
                     <a:lstStyle/>
                     <a:p>
                       <a:r>
+                        <a:rPr sz="1800" b="0">
+                          <a:solidFill>
+                            <a:srgbClr val="F8F8F2"/>
+                          </a:solidFill>
+                          <a:latin typeface="Segoe UI"/>
+                        </a:rPr>
                         <a:t>Faible isolation (un crash tue le processus)</a:t>
                       </a:r>
                     </a:p>
@@ -3757,6 +4404,12 @@
                     <a:lstStyle/>
                     <a:p>
                       <a:r>
+                        <a:rPr sz="1800" b="0">
+                          <a:solidFill>
+                            <a:srgbClr val="F8F8F2"/>
+                          </a:solidFill>
+                          <a:latin typeface="Segoe UI"/>
+                        </a:rPr>
                         <a:t>Communication (IPC) lente</a:t>
                       </a:r>
                     </a:p>
@@ -3769,6 +4422,12 @@
                     <a:lstStyle/>
                     <a:p>
                       <a:r>
+                        <a:rPr sz="1800" b="0">
+                          <a:solidFill>
+                            <a:srgbClr val="F8F8F2"/>
+                          </a:solidFill>
+                          <a:latin typeface="Segoe UI"/>
+                        </a:rPr>
                         <a:t>Communication très rapide</a:t>
                       </a:r>
                     </a:p>
@@ -3788,9 +4447,17 @@
 </p:sld>
 </file>
 
-<file path=ppt/slides/slide8.xml><?xml version="1.0" encoding="utf-8"?>
+<file path=ppt/slides/slide9.xml><?xml version="1.0" encoding="utf-8"?>
 <p:sld xmlns:a="http://schemas.openxmlformats.org/drawingml/2006/main" xmlns:p="http://schemas.openxmlformats.org/presentationml/2006/main" xmlns:r="http://schemas.openxmlformats.org/officeDocument/2006/relationships">
   <p:cSld>
+    <p:bg>
+      <p:bgPr>
+        <a:solidFill>
+          <a:srgbClr val="282A36"/>
+        </a:solidFill>
+        <a:effectLst/>
+      </p:bgPr>
+    </p:bg>
     <p:spTree>
       <p:nvGrpSpPr>
         <p:cNvPr id="1" name=""/>
@@ -3814,6 +4481,12 @@
           <a:lstStyle/>
           <a:p>
             <a:r>
+              <a:rPr sz="3600" b="1">
+                <a:solidFill>
+                  <a:srgbClr val="FF79C6"/>
+                </a:solidFill>
+                <a:latin typeface="Segoe UI"/>
+              </a:rPr>
               <a:t>Langages &amp; Concurrence</a:t>
             </a:r>
           </a:p>
@@ -3833,89 +4506,53 @@
         <p:txBody>
           <a:bodyPr/>
           <a:lstStyle/>
-          <a:p>
-            <a:r>
-              <a:t>Python : Le GIL limite à un seul thread actif à la fois (pas de vrai parallélisme CPU natif pour les threads).</a:t>
-            </a:r>
-          </a:p>
-          <a:p>
-            <a:r>
-              <a:t>Java / C++ : Threads OS natifs. Outils avancés (Pools, Futures). Très performants mais complexes.</a:t>
-            </a:r>
-          </a:p>
-          <a:p>
-            <a:r>
-              <a:t>Go / Node.js : Goroutines (Go) : ultra-légers. Event-loop (Node) : asynchronisme mono-thread.</a:t>
-            </a:r>
-          </a:p>
-        </p:txBody>
-      </p:sp>
-    </p:spTree>
-  </p:cSld>
-  <p:clrMapOvr>
-    <a:masterClrMapping/>
-  </p:clrMapOvr>
-</p:sld>
-</file>
-
-<file path=ppt/slides/slide9.xml><?xml version="1.0" encoding="utf-8"?>
-<p:sld xmlns:a="http://schemas.openxmlformats.org/drawingml/2006/main" xmlns:p="http://schemas.openxmlformats.org/presentationml/2006/main" xmlns:r="http://schemas.openxmlformats.org/officeDocument/2006/relationships">
-  <p:cSld>
-    <p:spTree>
-      <p:nvGrpSpPr>
-        <p:cNvPr id="1" name=""/>
-        <p:cNvGrpSpPr/>
-        <p:nvPr/>
-      </p:nvGrpSpPr>
-      <p:grpSpPr/>
-      <p:sp>
-        <p:nvSpPr>
-          <p:cNvPr id="2" name="Title 1"/>
-          <p:cNvSpPr>
-            <a:spLocks noGrp="1"/>
-          </p:cNvSpPr>
-          <p:nvPr>
-            <p:ph type="title"/>
-          </p:nvPr>
-        </p:nvSpPr>
-        <p:spPr/>
-        <p:txBody>
-          <a:bodyPr/>
-          <a:lstStyle/>
-          <a:p>
-            <a:r>
-              <a:t>Bonnes Pratiques ✅</a:t>
-            </a:r>
-          </a:p>
-        </p:txBody>
-      </p:sp>
-      <p:sp>
-        <p:nvSpPr>
-          <p:cNvPr id="3" name="Content Placeholder 2"/>
-          <p:cNvSpPr>
-            <a:spLocks noGrp="1"/>
-          </p:cNvSpPr>
-          <p:nvPr>
-            <p:ph idx="1"/>
-          </p:nvPr>
-        </p:nvSpPr>
-        <p:spPr/>
-        <p:txBody>
-          <a:bodyPr/>
-          <a:lstStyle/>
-          <a:p>
-            <a:r>
-              <a:t>Minimiser les données partagées entre les threads.</a:t>
-            </a:r>
-          </a:p>
-          <a:p>
-            <a:r>
-              <a:t>Garder les sections critiques (verrouillées) très courtes.</a:t>
-            </a:r>
-          </a:p>
-          <a:p>
-            <a:r>
-              <a:t>Toujours utiliser unlock() dans un bloc finally.</a:t>
+          <a:p/>
+          <a:p>
+            <a:pPr>
+              <a:spcAft>
+                <a:spcPts val="1400"/>
+              </a:spcAft>
+            </a:pPr>
+            <a:r>
+              <a:rPr sz="2200">
+                <a:solidFill>
+                  <a:srgbClr val="F8F8F2"/>
+                </a:solidFill>
+                <a:latin typeface="Segoe UI"/>
+              </a:rPr>
+              <a:t>🐍 Python : Le GIL limite le parallélisme CPU natif.</a:t>
+            </a:r>
+          </a:p>
+          <a:p>
+            <a:pPr>
+              <a:spcAft>
+                <a:spcPts val="1400"/>
+              </a:spcAft>
+            </a:pPr>
+            <a:r>
+              <a:rPr sz="2200">
+                <a:solidFill>
+                  <a:srgbClr val="F8F8F2"/>
+                </a:solidFill>
+                <a:latin typeface="Segoe UI"/>
+              </a:rPr>
+              <a:t>☕ Java / C++ : Threads OS natifs. Performants mais complexes.</a:t>
+            </a:r>
+          </a:p>
+          <a:p>
+            <a:pPr>
+              <a:spcAft>
+                <a:spcPts val="1400"/>
+              </a:spcAft>
+            </a:pPr>
+            <a:r>
+              <a:rPr sz="2200">
+                <a:solidFill>
+                  <a:srgbClr val="F8F8F2"/>
+                </a:solidFill>
+                <a:latin typeface="Segoe UI"/>
+              </a:rPr>
+              <a:t>🐹 Go / Node.js : Goroutines ultra-légers / asynchronisme mono-thread.</a:t>
             </a:r>
           </a:p>
         </p:txBody>

</xml_diff>